<commit_message>
update draft before edit
</commit_message>
<xml_diff>
--- a/docs/paper/figure_sources/figure1_dataset_characteristics/figure1_dataset_characteristics.pptx
+++ b/docs/paper/figure_sources/figure1_dataset_characteristics/figure1_dataset_characteristics.pptx
@@ -107,6 +107,11 @@
       </a:defRPr>
     </a:lvl9pPr>
   </p:defaultTextStyle>
+  <p:extLst>
+    <p:ext uri="{EFAFB233-063F-42B5-8137-9DF3F51BA10A}">
+      <p15:sldGuideLst xmlns:p15="http://schemas.microsoft.com/office/powerpoint/2012/main"/>
+    </p:ext>
+  </p:extLst>
 </p:presentation>
 </file>
 
@@ -4008,10 +4013,10 @@
                 <a:ea typeface="Arial"/>
                 <a:cs typeface="Arial"/>
               </a:rPr>
-              <a:t>Auxiliary Train + </a:t>
+              <a:t>Auxiliary Train </a:t>
             </a:r>
             <a:r>
-              <a:rPr lang="en-US" sz="720" b="0" dirty="0">
+              <a:rPr sz="720" b="0">
                 <a:solidFill>
                   <a:srgbClr val="526674"/>
                 </a:solidFill>
@@ -4019,19 +4024,16 @@
                 <a:ea typeface="Arial"/>
                 <a:cs typeface="Arial"/>
               </a:rPr>
-              <a:t>External </a:t>
+              <a:t>+ Test</a:t>
             </a:r>
-            <a:r>
-              <a:rPr sz="720" b="0" dirty="0">
-                <a:solidFill>
-                  <a:srgbClr val="526674"/>
-                </a:solidFill>
-                <a:latin typeface="Arial"/>
-                <a:ea typeface="Arial"/>
-                <a:cs typeface="Arial"/>
-              </a:rPr>
-              <a:t>Test</a:t>
-            </a:r>
+            <a:endParaRPr sz="720" b="0" dirty="0">
+              <a:solidFill>
+                <a:srgbClr val="526674"/>
+              </a:solidFill>
+              <a:latin typeface="Arial"/>
+              <a:ea typeface="Arial"/>
+              <a:cs typeface="Arial"/>
+            </a:endParaRPr>
           </a:p>
         </p:txBody>
       </p:sp>
@@ -7633,7 +7635,7 @@
               </a:defRPr>
             </a:pPr>
             <a:r>
-              <a:rPr sz="850" b="1">
+              <a:rPr sz="850" b="1" dirty="0">
                 <a:solidFill>
                   <a:srgbClr val="263D50"/>
                 </a:solidFill>
@@ -7641,7 +7643,7 @@
                 <a:ea typeface="Arial"/>
                 <a:cs typeface="Arial"/>
               </a:rPr>
-              <a:t>(b) Spectral PCA</a:t>
+              <a:t>(b)</a:t>
             </a:r>
           </a:p>
         </p:txBody>
@@ -38080,7 +38082,7 @@
         <p:spPr>
           <a:xfrm>
             <a:off x="1422400" y="1066800"/>
-            <a:ext cx="2476500" cy="127000"/>
+            <a:ext cx="203200" cy="127000"/>
           </a:xfrm>
           <a:prstGeom prst="rect">
             <a:avLst/>
@@ -38115,7 +38117,7 @@
                 <a:ea typeface="Arial"/>
                 <a:cs typeface="Arial"/>
               </a:rPr>
-              <a:t>(c) Median spectral centroid (Hz)</a:t>
+              <a:t>(c)</a:t>
             </a:r>
           </a:p>
         </p:txBody>
@@ -40715,13 +40717,7 @@
       </p:sp>
       <p:sp>
         <p:nvSpPr>
-          <p:cNvPr id="769" name="c/hf-scope">
-            <a:extLst>
-              <a:ext uri="{FF2B5EF4-FFF2-40B4-BE49-F238E27FC236}">
-                <a16:creationId xmlns:a16="http://schemas.microsoft.com/office/drawing/2014/main" id="{F44D8EA5-71FB-49F6-8052-1A1F75996EA1}"/>
-              </a:ext>
-            </a:extLst>
-          </p:cNvPr>
+          <p:cNvPr id="771" name="c/x-title"/>
           <p:cNvSpPr>
             <a:spLocks noGrp="1"/>
           </p:cNvSpPr>
@@ -40730,7 +40726,7 @@
         <p:spPr>
           <a:xfrm>
             <a:off x="1612900" y="1940560"/>
-            <a:ext cx="4744300" cy="91440"/>
+            <a:ext cx="4744301" cy="91440"/>
           </a:xfrm>
           <a:prstGeom prst="rect">
             <a:avLst/>
@@ -40749,7 +40745,7 @@
             <a:pPr algn="ctr">
               <a:defRPr sz="700" b="0">
                 <a:solidFill>
-                  <a:srgbClr val="526674"/>
+                  <a:srgbClr val="263D50"/>
                 </a:solidFill>
                 <a:latin typeface="Arial"/>
                 <a:ea typeface="Arial"/>
@@ -40759,13 +40755,87 @@
             <a:r>
               <a:rPr sz="700" b="0">
                 <a:solidFill>
-                  <a:srgbClr val="526674"/>
+                  <a:srgbClr val="263D50"/>
                 </a:solidFill>
                 <a:latin typeface="Arial"/>
                 <a:ea typeface="Arial"/>
                 <a:cs typeface="Arial"/>
               </a:rPr>
-              <a:t>HF: observed C/W combinations; Normal is unavailable.</a:t>
+              <a:t>Sound label</a:t>
+            </a:r>
+          </a:p>
+        </p:txBody>
+      </p:sp>
+      <p:sp>
+        <p:nvSpPr>
+          <p:cNvPr id="772" name="c/y-title"/>
+          <p:cNvSpPr>
+            <a:spLocks noGrp="1"/>
+          </p:cNvSpPr>
+          <p:nvPr/>
+        </p:nvSpPr>
+        <p:spPr>
+          <a:xfrm rot="16200000">
+            <a:off x="952500" y="1423670"/>
+            <a:ext cx="660400" cy="213360"/>
+          </a:xfrm>
+          <a:prstGeom prst="rect">
+            <a:avLst/>
+          </a:prstGeom>
+          <a:noFill/>
+          <a:ln w="0">
+            <a:noFill/>
+          </a:ln>
+        </p:spPr>
+        <p:txBody>
+          <a:bodyPr wrap="none" lIns="0" tIns="0" rIns="0" bIns="0" anchor="ctr">
+            <a:noAutofit/>
+          </a:bodyPr>
+          <a:lstStyle/>
+          <a:p>
+            <a:pPr algn="ctr">
+              <a:defRPr sz="700" b="0">
+                <a:solidFill>
+                  <a:srgbClr val="263D50"/>
+                </a:solidFill>
+                <a:latin typeface="Arial"/>
+                <a:ea typeface="Arial"/>
+                <a:cs typeface="Arial"/>
+              </a:defRPr>
+            </a:pPr>
+            <a:r>
+              <a:rPr sz="700" b="0">
+                <a:solidFill>
+                  <a:srgbClr val="263D50"/>
+                </a:solidFill>
+                <a:latin typeface="Arial"/>
+                <a:ea typeface="Arial"/>
+                <a:cs typeface="Arial"/>
+              </a:rPr>
+              <a:t>Median spectral</a:t>
+            </a:r>
+          </a:p>
+          <a:p>
+            <a:pPr algn="ctr">
+              <a:defRPr sz="700" b="0">
+                <a:solidFill>
+                  <a:srgbClr val="263D50"/>
+                </a:solidFill>
+                <a:latin typeface="Arial"/>
+                <a:ea typeface="Arial"/>
+                <a:cs typeface="Arial"/>
+              </a:defRPr>
+            </a:pPr>
+            <a:r>
+              <a:rPr sz="700" b="0">
+                <a:solidFill>
+                  <a:srgbClr val="263D50"/>
+                </a:solidFill>
+                <a:latin typeface="Arial"/>
+                <a:ea typeface="Arial"/>
+                <a:cs typeface="Arial"/>
+              </a:rPr>
+              <a:t>centroid (Hz)</a:t>
             </a:r>
           </a:p>
         </p:txBody>

</xml_diff>